<commit_message>
Restore approved mentor prose and replace Figures 2, 4 and 5
Apply conservative restoration with the approved Q4 comparison and Q5 6/2/2 scoring. Preserve the 85-record pool, 78 cited sources and 13 core studies.

Include the selected figure PDFs, editable PPTX files and restoration/replacement audit records. Figure 4 semantic issues remain documented for follow-up.
</commit_message>
<xml_diff>
--- a/output/figure2_editable/20261013-153831-codex-clipboard-1eb7c158-b30c-49e1-bfa6-5ae40fd6f410/final/codex-clipboard-1eb7c158-b30c-49e1-bfa6-5ae40fd6f410_edited.pptx
+++ b/output/figure2_editable/20261013-153831-codex-clipboard-1eb7c158-b30c-49e1-bfa6-5ae40fd6f410/final/codex-clipboard-1eb7c158-b30c-49e1-bfa6-5ae40fd6f410_edited.pptx
@@ -104,6 +104,11 @@
       </a:defRPr>
     </a:lvl9pPr>
   </p:defaultTextStyle>
+  <p:extLst>
+    <p:ext uri="{EFAFB233-063F-42B5-8137-9DF3F51BA10A}">
+      <p15:sldGuideLst xmlns:p15="http://schemas.microsoft.com/office/powerpoint/2012/main"/>
+    </p:ext>
+  </p:extLst>
 </p:presentation>
 </file>
 
@@ -4113,7 +4118,7 @@
           <a:p>
             <a:pPr algn="ctr"/>
             <a:r>
-              <a:rPr lang="zh-CN" sz="850" dirty="0">
+              <a:rPr lang="zh-CN" sz="600" dirty="0">
                 <a:solidFill>
                   <a:srgbClr val="596571"/>
                 </a:solidFill>
@@ -4123,7 +4128,7 @@
               </a:rPr>
               <a:t>Representative milestones; paradigms overlap and continue to coexist.</a:t>
             </a:r>
-            <a:endParaRPr lang="zh-CN" sz="850" dirty="0"/>
+            <a:endParaRPr lang="zh-CN" sz="600" dirty="0"/>
           </a:p>
         </p:txBody>
       </p:sp>

</xml_diff>

<commit_message>
Update editable sources for Figures 2, 4, and 5
</commit_message>
<xml_diff>
--- a/output/figure2_editable/20261013-153831-codex-clipboard-1eb7c158-b30c-49e1-bfa6-5ae40fd6f410/final/codex-clipboard-1eb7c158-b30c-49e1-bfa6-5ae40fd6f410_edited.pptx
+++ b/output/figure2_editable/20261013-153831-codex-clipboard-1eb7c158-b30c-49e1-bfa6-5ae40fd6f410/final/codex-clipboard-1eb7c158-b30c-49e1-bfa6-5ae40fd6f410_edited.pptx
@@ -3211,7 +3211,7 @@
           <a:p>
             <a:pPr algn="ctr"/>
             <a:r>
-              <a:rPr lang="zh-CN" sz="630" b="1" dirty="0">
+              <a:rPr lang="zh-CN" sz="800" b="1" dirty="0">
                 <a:solidFill>
                   <a:srgbClr val="202B3A"/>
                 </a:solidFill>
@@ -3221,7 +3221,7 @@
               </a:rPr>
               <a:t>1960s onward</a:t>
             </a:r>
-            <a:endParaRPr lang="zh-CN" sz="630" dirty="0"/>
+            <a:endParaRPr lang="zh-CN" sz="800" dirty="0"/>
           </a:p>
         </p:txBody>
       </p:sp>
@@ -3252,7 +3252,7 @@
           <a:p>
             <a:pPr algn="ctr"/>
             <a:r>
-              <a:rPr lang="zh-CN" sz="630" b="1" dirty="0">
+              <a:rPr lang="zh-CN" sz="800" b="1" dirty="0">
                 <a:solidFill>
                   <a:srgbClr val="202B3A"/>
                 </a:solidFill>
@@ -3262,12 +3262,12 @@
               </a:rPr>
               <a:t>Symbolic</a:t>
             </a:r>
-            <a:endParaRPr lang="zh-CN" sz="630" dirty="0"/>
+            <a:endParaRPr lang="zh-CN" sz="800" dirty="0"/>
           </a:p>
           <a:p>
             <a:pPr algn="ctr"/>
             <a:r>
-              <a:rPr lang="zh-CN" sz="630" b="1" dirty="0">
+              <a:rPr lang="zh-CN" sz="800" b="1" dirty="0">
                 <a:solidFill>
                   <a:srgbClr val="202B3A"/>
                 </a:solidFill>
@@ -3277,7 +3277,7 @@
               </a:rPr>
               <a:t>approaches</a:t>
             </a:r>
-            <a:endParaRPr lang="zh-CN" sz="630" dirty="0"/>
+            <a:endParaRPr lang="zh-CN" sz="800" dirty="0"/>
           </a:p>
         </p:txBody>
       </p:sp>
@@ -3308,7 +3308,7 @@
           <a:p>
             <a:pPr algn="ctr"/>
             <a:r>
-              <a:rPr lang="zh-CN" sz="730" dirty="0">
+              <a:rPr lang="zh-CN" sz="800" dirty="0">
                 <a:solidFill>
                   <a:srgbClr val="202B3A"/>
                 </a:solidFill>
@@ -3318,12 +3318,12 @@
               </a:rPr>
               <a:t>ELIZA (1966)</a:t>
             </a:r>
-            <a:endParaRPr lang="zh-CN" sz="730" dirty="0"/>
+            <a:endParaRPr lang="zh-CN" sz="800" dirty="0"/>
           </a:p>
           <a:p>
             <a:pPr algn="ctr"/>
             <a:r>
-              <a:rPr lang="zh-CN" sz="730" dirty="0">
+              <a:rPr lang="zh-CN" sz="800" dirty="0">
                 <a:solidFill>
                   <a:srgbClr val="202B3A"/>
                 </a:solidFill>
@@ -3333,7 +3333,7 @@
               </a:rPr>
               <a:t>Prolog, Cyc</a:t>
             </a:r>
-            <a:endParaRPr lang="zh-CN" sz="730" dirty="0"/>
+            <a:endParaRPr lang="zh-CN" sz="800" dirty="0"/>
           </a:p>
         </p:txBody>
       </p:sp>
@@ -3364,7 +3364,7 @@
           <a:p>
             <a:pPr algn="ctr"/>
             <a:r>
-              <a:rPr lang="zh-CN" sz="730" dirty="0">
+              <a:rPr lang="zh-CN" sz="800" dirty="0">
                 <a:solidFill>
                   <a:srgbClr val="202B3A"/>
                 </a:solidFill>
@@ -3374,12 +3374,12 @@
               </a:rPr>
               <a:t>Rules &amp; logic</a:t>
             </a:r>
-            <a:endParaRPr lang="zh-CN" sz="730" dirty="0"/>
+            <a:endParaRPr lang="zh-CN" sz="800" dirty="0"/>
           </a:p>
           <a:p>
             <a:pPr algn="ctr"/>
             <a:r>
-              <a:rPr lang="zh-CN" sz="730" dirty="0">
+              <a:rPr lang="zh-CN" sz="800" dirty="0">
                 <a:solidFill>
                   <a:srgbClr val="202B3A"/>
                 </a:solidFill>
@@ -3389,7 +3389,7 @@
               </a:rPr>
               <a:t>Knowledge representation</a:t>
             </a:r>
-            <a:endParaRPr lang="zh-CN" sz="730" dirty="0"/>
+            <a:endParaRPr lang="zh-CN" sz="800" dirty="0"/>
           </a:p>
         </p:txBody>
       </p:sp>
@@ -3420,7 +3420,7 @@
           <a:p>
             <a:pPr algn="ctr"/>
             <a:r>
-              <a:rPr lang="zh-CN" sz="630" b="1" dirty="0">
+              <a:rPr lang="zh-CN" sz="800" b="1" dirty="0">
                 <a:solidFill>
                   <a:srgbClr val="202B3A"/>
                 </a:solidFill>
@@ -3430,7 +3430,7 @@
               </a:rPr>
               <a:t>1990s onward</a:t>
             </a:r>
-            <a:endParaRPr lang="zh-CN" sz="630" dirty="0"/>
+            <a:endParaRPr lang="zh-CN" sz="800" dirty="0"/>
           </a:p>
         </p:txBody>
       </p:sp>
@@ -3461,7 +3461,7 @@
           <a:p>
             <a:pPr algn="ctr"/>
             <a:r>
-              <a:rPr lang="zh-CN" sz="630" b="1" dirty="0">
+              <a:rPr lang="zh-CN" sz="800" b="1" dirty="0">
                 <a:solidFill>
                   <a:srgbClr val="202B3A"/>
                 </a:solidFill>
@@ -3471,12 +3471,12 @@
               </a:rPr>
               <a:t>Retrieval &amp; reading</a:t>
             </a:r>
-            <a:endParaRPr lang="zh-CN" sz="630" dirty="0"/>
+            <a:endParaRPr lang="zh-CN" sz="800" dirty="0"/>
           </a:p>
           <a:p>
             <a:pPr algn="ctr"/>
             <a:r>
-              <a:rPr lang="zh-CN" sz="630" b="1" dirty="0">
+              <a:rPr lang="zh-CN" sz="800" b="1" dirty="0">
                 <a:solidFill>
                   <a:srgbClr val="202B3A"/>
                 </a:solidFill>
@@ -3486,7 +3486,7 @@
               </a:rPr>
               <a:t>comprehension</a:t>
             </a:r>
-            <a:endParaRPr lang="zh-CN" sz="630" dirty="0"/>
+            <a:endParaRPr lang="zh-CN" sz="800" dirty="0"/>
           </a:p>
         </p:txBody>
       </p:sp>
@@ -3517,7 +3517,7 @@
           <a:p>
             <a:pPr algn="ctr"/>
             <a:r>
-              <a:rPr lang="zh-CN" sz="730" dirty="0">
+              <a:rPr lang="zh-CN" sz="800" dirty="0">
                 <a:solidFill>
                   <a:srgbClr val="202B3A"/>
                 </a:solidFill>
@@ -3527,12 +3527,12 @@
               </a:rPr>
               <a:t>TREC QA (1999)</a:t>
             </a:r>
-            <a:endParaRPr lang="zh-CN" sz="730" dirty="0"/>
+            <a:endParaRPr lang="zh-CN" sz="800" dirty="0"/>
           </a:p>
           <a:p>
             <a:pPr algn="ctr"/>
             <a:r>
-              <a:rPr lang="zh-CN" sz="730" dirty="0">
+              <a:rPr lang="zh-CN" sz="800" dirty="0">
                 <a:solidFill>
                   <a:srgbClr val="202B3A"/>
                 </a:solidFill>
@@ -3542,12 +3542,12 @@
               </a:rPr>
               <a:t>Web search</a:t>
             </a:r>
-            <a:endParaRPr lang="zh-CN" sz="730" dirty="0"/>
+            <a:endParaRPr lang="zh-CN" sz="800" dirty="0"/>
           </a:p>
           <a:p>
             <a:pPr algn="ctr"/>
             <a:r>
-              <a:rPr lang="zh-CN" sz="730" dirty="0">
+              <a:rPr lang="zh-CN" sz="800" dirty="0">
                 <a:solidFill>
                   <a:srgbClr val="202B3A"/>
                 </a:solidFill>
@@ -3557,7 +3557,7 @@
               </a:rPr>
               <a:t>SQuAD (2016)</a:t>
             </a:r>
-            <a:endParaRPr lang="zh-CN" sz="730" dirty="0"/>
+            <a:endParaRPr lang="zh-CN" sz="800" dirty="0"/>
           </a:p>
         </p:txBody>
       </p:sp>
@@ -3588,7 +3588,7 @@
           <a:p>
             <a:pPr algn="ctr"/>
             <a:r>
-              <a:rPr lang="zh-CN" sz="730" dirty="0">
+              <a:rPr lang="zh-CN" sz="800" dirty="0">
                 <a:solidFill>
                   <a:srgbClr val="202B3A"/>
                 </a:solidFill>
@@ -3598,12 +3598,12 @@
               </a:rPr>
               <a:t>Document retrieval</a:t>
             </a:r>
-            <a:endParaRPr lang="zh-CN" sz="730" dirty="0"/>
+            <a:endParaRPr lang="zh-CN" sz="800" dirty="0"/>
           </a:p>
           <a:p>
             <a:pPr algn="ctr"/>
             <a:r>
-              <a:rPr lang="zh-CN" sz="730" dirty="0">
+              <a:rPr lang="zh-CN" sz="800" dirty="0">
                 <a:solidFill>
                   <a:srgbClr val="202B3A"/>
                 </a:solidFill>
@@ -3613,7 +3613,7 @@
               </a:rPr>
               <a:t>Answer extraction</a:t>
             </a:r>
-            <a:endParaRPr lang="zh-CN" sz="730" dirty="0"/>
+            <a:endParaRPr lang="zh-CN" sz="800" dirty="0"/>
           </a:p>
         </p:txBody>
       </p:sp>
@@ -3644,7 +3644,7 @@
           <a:p>
             <a:pPr algn="ctr"/>
             <a:r>
-              <a:rPr lang="zh-CN" sz="630" b="1" dirty="0">
+              <a:rPr lang="zh-CN" sz="800" b="1" dirty="0">
                 <a:solidFill>
                   <a:srgbClr val="202B3A"/>
                 </a:solidFill>
@@ -3654,7 +3654,7 @@
               </a:rPr>
               <a:t>2010s onward</a:t>
             </a:r>
-            <a:endParaRPr lang="zh-CN" sz="630" dirty="0"/>
+            <a:endParaRPr lang="zh-CN" sz="800" dirty="0"/>
           </a:p>
         </p:txBody>
       </p:sp>
@@ -3685,7 +3685,7 @@
           <a:p>
             <a:pPr algn="ctr"/>
             <a:r>
-              <a:rPr lang="zh-CN" sz="630" b="1" dirty="0">
+              <a:rPr lang="zh-CN" sz="800" b="1" dirty="0">
                 <a:solidFill>
                   <a:srgbClr val="202B3A"/>
                 </a:solidFill>
@@ -3695,12 +3695,12 @@
               </a:rPr>
               <a:t>Neural &amp;</a:t>
             </a:r>
-            <a:endParaRPr lang="zh-CN" sz="630" dirty="0"/>
+            <a:endParaRPr lang="zh-CN" sz="800" dirty="0"/>
           </a:p>
           <a:p>
             <a:pPr algn="ctr"/>
             <a:r>
-              <a:rPr lang="zh-CN" sz="630" b="1" dirty="0">
+              <a:rPr lang="zh-CN" sz="800" b="1" dirty="0">
                 <a:solidFill>
                   <a:srgbClr val="202B3A"/>
                 </a:solidFill>
@@ -3710,7 +3710,7 @@
               </a:rPr>
               <a:t>generative QA</a:t>
             </a:r>
-            <a:endParaRPr lang="zh-CN" sz="630" dirty="0"/>
+            <a:endParaRPr lang="zh-CN" sz="800" dirty="0"/>
           </a:p>
         </p:txBody>
       </p:sp>
@@ -3741,7 +3741,7 @@
           <a:p>
             <a:pPr algn="ctr"/>
             <a:r>
-              <a:rPr lang="zh-CN" sz="730" dirty="0">
+              <a:rPr lang="zh-CN" sz="800" dirty="0">
                 <a:solidFill>
                   <a:srgbClr val="202B3A"/>
                 </a:solidFill>
@@ -3751,12 +3751,12 @@
               </a:rPr>
               <a:t>Transformer</a:t>
             </a:r>
-            <a:endParaRPr lang="zh-CN" sz="730" dirty="0"/>
+            <a:endParaRPr lang="zh-CN" sz="800" dirty="0"/>
           </a:p>
           <a:p>
             <a:pPr algn="ctr"/>
             <a:r>
-              <a:rPr lang="zh-CN" sz="730" dirty="0">
+              <a:rPr lang="zh-CN" sz="800" dirty="0">
                 <a:solidFill>
                   <a:srgbClr val="202B3A"/>
                 </a:solidFill>
@@ -3766,12 +3766,12 @@
               </a:rPr>
               <a:t>BERT, GPT-2/3</a:t>
             </a:r>
-            <a:endParaRPr lang="zh-CN" sz="730" dirty="0"/>
+            <a:endParaRPr lang="zh-CN" sz="800" dirty="0"/>
           </a:p>
           <a:p>
             <a:pPr algn="ctr"/>
             <a:r>
-              <a:rPr lang="zh-CN" sz="730" dirty="0">
+              <a:rPr lang="zh-CN" sz="800" dirty="0">
                 <a:solidFill>
                   <a:srgbClr val="202B3A"/>
                 </a:solidFill>
@@ -3781,7 +3781,7 @@
               </a:rPr>
               <a:t>T5</a:t>
             </a:r>
-            <a:endParaRPr lang="zh-CN" sz="730" dirty="0"/>
+            <a:endParaRPr lang="zh-CN" sz="800" dirty="0"/>
           </a:p>
         </p:txBody>
       </p:sp>
@@ -3812,7 +3812,7 @@
           <a:p>
             <a:pPr algn="ctr"/>
             <a:r>
-              <a:rPr lang="zh-CN" sz="730" dirty="0">
+              <a:rPr lang="zh-CN" sz="800" dirty="0">
                 <a:solidFill>
                   <a:srgbClr val="202B3A"/>
                 </a:solidFill>
@@ -3822,12 +3822,12 @@
               </a:rPr>
               <a:t>Pretraining &amp; fine-tuning</a:t>
             </a:r>
-            <a:endParaRPr lang="zh-CN" sz="730" dirty="0"/>
+            <a:endParaRPr lang="zh-CN" sz="800" dirty="0"/>
           </a:p>
           <a:p>
             <a:pPr algn="ctr"/>
             <a:r>
-              <a:rPr lang="zh-CN" sz="730" dirty="0">
+              <a:rPr lang="zh-CN" sz="800" dirty="0">
                 <a:solidFill>
                   <a:srgbClr val="202B3A"/>
                 </a:solidFill>
@@ -3837,7 +3837,7 @@
               </a:rPr>
               <a:t>RAG (2020), CoT (2022)</a:t>
             </a:r>
-            <a:endParaRPr lang="zh-CN" sz="730" dirty="0"/>
+            <a:endParaRPr lang="zh-CN" sz="800" dirty="0"/>
           </a:p>
         </p:txBody>
       </p:sp>
@@ -3868,7 +3868,7 @@
           <a:p>
             <a:pPr algn="ctr"/>
             <a:r>
-              <a:rPr lang="zh-CN" sz="630" b="1" dirty="0">
+              <a:rPr lang="zh-CN" sz="800" b="1" dirty="0">
                 <a:solidFill>
                   <a:srgbClr val="202B3A"/>
                 </a:solidFill>
@@ -3878,7 +3878,7 @@
               </a:rPr>
               <a:t>2022 onward</a:t>
             </a:r>
-            <a:endParaRPr lang="zh-CN" sz="630" dirty="0"/>
+            <a:endParaRPr lang="zh-CN" sz="800" dirty="0"/>
           </a:p>
         </p:txBody>
       </p:sp>
@@ -3909,7 +3909,7 @@
           <a:p>
             <a:pPr algn="ctr"/>
             <a:r>
-              <a:rPr lang="zh-CN" sz="630" b="1" dirty="0">
+              <a:rPr lang="zh-CN" sz="800" b="1" dirty="0">
                 <a:solidFill>
                   <a:srgbClr val="202B3A"/>
                 </a:solidFill>
@@ -3919,12 +3919,12 @@
               </a:rPr>
               <a:t>LLM-based</a:t>
             </a:r>
-            <a:endParaRPr lang="zh-CN" sz="630" dirty="0"/>
+            <a:endParaRPr lang="zh-CN" sz="800" dirty="0"/>
           </a:p>
           <a:p>
             <a:pPr algn="ctr"/>
             <a:r>
-              <a:rPr lang="zh-CN" sz="630" b="1" dirty="0">
+              <a:rPr lang="zh-CN" sz="800" b="1" dirty="0">
                 <a:solidFill>
                   <a:srgbClr val="202B3A"/>
                 </a:solidFill>
@@ -3934,7 +3934,7 @@
               </a:rPr>
               <a:t>agentic QA</a:t>
             </a:r>
-            <a:endParaRPr lang="zh-CN" sz="630" dirty="0"/>
+            <a:endParaRPr lang="zh-CN" sz="800" dirty="0"/>
           </a:p>
         </p:txBody>
       </p:sp>
@@ -3965,7 +3965,7 @@
           <a:p>
             <a:pPr algn="ctr"/>
             <a:r>
-              <a:rPr lang="zh-CN" sz="730" dirty="0">
+              <a:rPr lang="zh-CN" sz="800" dirty="0">
                 <a:solidFill>
                   <a:srgbClr val="202B3A"/>
                 </a:solidFill>
@@ -3975,12 +3975,12 @@
               </a:rPr>
               <a:t>ReAct (2022/2023)</a:t>
             </a:r>
-            <a:endParaRPr lang="zh-CN" sz="730" dirty="0"/>
+            <a:endParaRPr lang="zh-CN" sz="800" dirty="0"/>
           </a:p>
           <a:p>
             <a:pPr algn="ctr"/>
             <a:r>
-              <a:rPr lang="zh-CN" sz="730" dirty="0">
+              <a:rPr lang="zh-CN" sz="800" dirty="0">
                 <a:solidFill>
                   <a:srgbClr val="202B3A"/>
                 </a:solidFill>
@@ -3990,7 +3990,7 @@
               </a:rPr>
               <a:t>GPT-4, Gemini (2023)</a:t>
             </a:r>
-            <a:endParaRPr lang="zh-CN" sz="730" dirty="0"/>
+            <a:endParaRPr lang="zh-CN" sz="800" dirty="0"/>
           </a:p>
         </p:txBody>
       </p:sp>
@@ -4021,7 +4021,7 @@
           <a:p>
             <a:pPr algn="ctr"/>
             <a:r>
-              <a:rPr lang="zh-CN" sz="730" dirty="0">
+              <a:rPr lang="zh-CN" sz="800" dirty="0">
                 <a:solidFill>
                   <a:srgbClr val="202B3A"/>
                 </a:solidFill>
@@ -4031,12 +4031,12 @@
               </a:rPr>
               <a:t>Tool use</a:t>
             </a:r>
-            <a:endParaRPr lang="zh-CN" sz="730" dirty="0"/>
+            <a:endParaRPr lang="zh-CN" sz="800" dirty="0"/>
           </a:p>
           <a:p>
             <a:pPr algn="ctr"/>
             <a:r>
-              <a:rPr lang="zh-CN" sz="730" dirty="0">
+              <a:rPr lang="zh-CN" sz="800" dirty="0">
                 <a:solidFill>
                   <a:srgbClr val="202B3A"/>
                 </a:solidFill>
@@ -4046,7 +4046,7 @@
               </a:rPr>
               <a:t>Multi-agent collaboration</a:t>
             </a:r>
-            <a:endParaRPr lang="zh-CN" sz="730" dirty="0"/>
+            <a:endParaRPr lang="zh-CN" sz="800" dirty="0"/>
           </a:p>
         </p:txBody>
       </p:sp>
@@ -4118,7 +4118,7 @@
           <a:p>
             <a:pPr algn="ctr"/>
             <a:r>
-              <a:rPr lang="zh-CN" sz="600" dirty="0">
+              <a:rPr lang="zh-CN" sz="800" dirty="0">
                 <a:solidFill>
                   <a:srgbClr val="596571"/>
                 </a:solidFill>
@@ -4128,7 +4128,7 @@
               </a:rPr>
               <a:t>Representative milestones; paradigms overlap and continue to coexist.</a:t>
             </a:r>
-            <a:endParaRPr lang="zh-CN" sz="600" dirty="0"/>
+            <a:endParaRPr lang="zh-CN" sz="800" dirty="0"/>
           </a:p>
         </p:txBody>
       </p:sp>

</xml_diff>